<commit_message>
One legend label for deterministic boxes; report-back point instead of chatbot question
The light-blue boxes were labelled "deterministic" on one slide and
"tool" or "system" on others. They now read "deterministic" everywhere,
in both decks. The ten-minute exercise ends with one point per group to
present (where the agent decided, where a person did) and says that
everything happens in the app.

Co-Authored-By: Claude Fable 5.1 <noreply@anthropic.com>
Claude-Session: https://claude.ai/code/session_013LaU8KutyVc6GAVj7UGghE
</commit_message>
<xml_diff>
--- a/slides/agent-10-minute-exercise.pptx
+++ b/slides/agent-10-minute-exercise.pptx
@@ -524,7 +524,7 @@
           <a:lstStyle/>
           <a:p>
             <a:r>
-              <a:t>Ten minutes, strict. Say the workshop code once, do not type it in chat. If a group finishes early, ask them to untick the triage sub-agent in the building blocks and send the first prompt again: the orchestrator then does the labelling itself and the trace flattens.</a:t>
+              <a:t>Ten minutes, strict. Say the workshop code once, do not type it in chat. Everything happens in the app; nobody needs another tool. Close by asking each group for its one sentence on where the agent decided and where a person did. If a group finishes early, ask them to untick the triage sub-agent in the building blocks and send the first prompt again: the orchestrator then does the labelling itself and the trace flattens.</a:t>
             </a:r>
           </a:p>
         </p:txBody>
@@ -7793,7 +7793,7 @@
                 </a:solidFill>
                 <a:latin typeface="Arial"/>
               </a:rPr>
-              <a:t>Agree one sentence</a:t>
+              <a:t>Prepare one point to present</a:t>
             </a:r>
           </a:p>
         </p:txBody>
@@ -7832,7 +7832,7 @@
                 </a:solidFill>
                 <a:latin typeface="Arial"/>
               </a:rPr>
-              <a:t>What did the agent do that a chatbot could not, and where did a person stay in the loop?</a:t>
+              <a:t>Where did the agent decide on its own, and where did a person still have to decide? One sentence per group, read out at the end.</a:t>
             </a:r>
           </a:p>
         </p:txBody>
@@ -8003,6 +8003,22 @@
                 <a:latin typeface="Arial"/>
               </a:rPr>
               <a:t>The draft to an outside address waits for a person</a:t>
+            </a:r>
+          </a:p>
+          <a:p>
+            <a:pPr algn="l">
+              <a:spcAft>
+                <a:spcPts val="500"/>
+              </a:spcAft>
+            </a:pPr>
+            <a:r>
+              <a:rPr sz="1200" b="0" i="0">
+                <a:solidFill>
+                  <a:srgbClr val="000000"/>
+                </a:solidFill>
+                <a:latin typeface="Arial"/>
+              </a:rPr>
+              <a:t>Everything happens in the app: no other tool is needed</a:t>
             </a:r>
           </a:p>
         </p:txBody>
@@ -12245,7 +12261,7 @@
                 </a:solidFill>
                 <a:latin typeface="Arial"/>
               </a:rPr>
-              <a:t>tool</a:t>
+              <a:t>deterministic</a:t>
             </a:r>
           </a:p>
         </p:txBody>
@@ -15725,7 +15741,7 @@
                 </a:solidFill>
                 <a:latin typeface="Arial"/>
               </a:rPr>
-              <a:t>tool</a:t>
+              <a:t>deterministic</a:t>
             </a:r>
           </a:p>
         </p:txBody>

</xml_diff>

<commit_message>
Sync slides from the law branch
Co-Authored-By: Claude Fable 5.1 <noreply@anthropic.com>
Claude-Session: https://claude.ai/code/session_013LaU8KutyVc6GAVj7UGghE
</commit_message>
<xml_diff>
--- a/slides/agent-10-minute-exercise.pptx
+++ b/slides/agent-10-minute-exercise.pptx
@@ -524,7 +524,7 @@
           <a:lstStyle/>
           <a:p>
             <a:r>
-              <a:t>Ten minutes, strict. Say the workshop code once, do not type it in chat. If a group finishes early, ask them to untick the triage sub-agent in the building blocks and send the first prompt again: the orchestrator then does the labelling itself and the trace flattens.</a:t>
+              <a:t>Ten minutes, strict. Say the workshop code once, do not type it in chat. Everything happens in the app; nobody needs another tool. Close by asking each group for its one sentence on where the agent decided and where a person did. If a group finishes early, ask them to untick the triage sub-agent in the building blocks and send the first prompt again: the orchestrator then does the labelling itself and the trace flattens.</a:t>
             </a:r>
           </a:p>
         </p:txBody>
@@ -7793,7 +7793,7 @@
                 </a:solidFill>
                 <a:latin typeface="Arial"/>
               </a:rPr>
-              <a:t>Agree one sentence</a:t>
+              <a:t>Prepare one point to present</a:t>
             </a:r>
           </a:p>
         </p:txBody>
@@ -7832,7 +7832,7 @@
                 </a:solidFill>
                 <a:latin typeface="Arial"/>
               </a:rPr>
-              <a:t>What did the agent do that a chatbot could not, and where did a person stay in the loop?</a:t>
+              <a:t>Where did the agent decide on its own, and where did a person still have to decide? One sentence per group, read out at the end.</a:t>
             </a:r>
           </a:p>
         </p:txBody>
@@ -8003,6 +8003,22 @@
                 <a:latin typeface="Arial"/>
               </a:rPr>
               <a:t>The draft to an outside address waits for a person</a:t>
+            </a:r>
+          </a:p>
+          <a:p>
+            <a:pPr algn="l">
+              <a:spcAft>
+                <a:spcPts val="500"/>
+              </a:spcAft>
+            </a:pPr>
+            <a:r>
+              <a:rPr sz="1200" b="0" i="0">
+                <a:solidFill>
+                  <a:srgbClr val="000000"/>
+                </a:solidFill>
+                <a:latin typeface="Arial"/>
+              </a:rPr>
+              <a:t>Everything happens in the app: no other tool is needed</a:t>
             </a:r>
           </a:p>
         </p:txBody>
@@ -12245,7 +12261,7 @@
                 </a:solidFill>
                 <a:latin typeface="Arial"/>
               </a:rPr>
-              <a:t>tool</a:t>
+              <a:t>deterministic</a:t>
             </a:r>
           </a:p>
         </p:txBody>
@@ -15725,7 +15741,7 @@
                 </a:solidFill>
                 <a:latin typeface="Arial"/>
               </a:rPr>
-              <a:t>tool</a:t>
+              <a:t>deterministic</a:t>
             </a:r>
           </a:p>
         </p:txBody>

</xml_diff>

<commit_message>
Challenge 2 is now about drafting a reply to the union
Challenge 1 keeps only the part that works: weaken the brief, watch what
holds, put it back. Challenge 2 asks for a draft to the union about the
Plant 2 grievance, rejects it with a reason, then moves the rule into the
brief. The step that removed the code guardrail is gone: the model
refuses the trap on its own, so it never produced a card.

Co-Authored-By: Claude Fable 5.1 <noreply@anthropic.com>
Claude-Session: https://claude.ai/code/session_013LaU8KutyVc6GAVj7UGghE
</commit_message>
<xml_diff>
--- a/slides/agent-10-minute-exercise.pptx
+++ b/slides/agent-10-minute-exercise.pptx
@@ -596,7 +596,7 @@
           <a:lstStyle/>
           <a:p>
             <a:r>
-              <a:t>Step A shows that the refusal of the trap came from the brief. Step B shows that the forward is still refused, by code: Confidential emails never leave the organisation. Step C shows the brief doing its real job, steering judgement. Land the question: policy that must hold goes in code, not in prose.</a:t>
+              <a:t>Step A removes the instruction that made the refusal explicit. In step B two things can happen, and both make the point: the model may still refuse on its own judgement, or it attempts the forward and the forward_email tool blocks it because the emails are Confidential and the address is outside the organisation. Step C shows the brief doing its job: the refusal is immediate and explained. Land the question: policy that must hold goes in code, not in prose. Do not try to make the agent actually send: the model's own judgement is a line you cannot switch off, which is itself worth saying.</a:t>
             </a:r>
           </a:p>
         </p:txBody>
@@ -666,7 +666,7 @@
           <a:lstStyle/>
           <a:p>
             <a:r>
-              <a:t>Step A is the human line: the limit is code, the decision is yours, and the agent has to live with it. Step B is pure code: Health &amp; Safety can never be archived, however the agent was persuaded. Step C strips the first two lines so that the person is visibly the last one. Close on the question; the usual answer is code for what must never happen, a person for what is expensive to get wrong, the brief for everything else.</a:t>
+              <a:t>Step A: the card appears because marta.visser is outside the organisation; the content is whatever the brief and the email suggested, and the first draft often offers to send the correspondence, which is confidential. Step B: the rejection text is literally what the agent receives as an error, so a precise reason produces a precise redraft; a vague one does not. Step C: the same rule now lives in the brief and the draft needs no correction, but the card still appears, because it is code. If a group has time, ask for a reply to Bram Jansen, the employee who raised the complaint: it goes straight to the outbox with no card, because he is internal. Ask whether that is right.</a:t>
             </a:r>
           </a:p>
         </p:txBody>
@@ -8404,7 +8404,7 @@
                 </a:solidFill>
                 <a:latin typeface="Arial"/>
               </a:rPr>
-              <a:t>The brief is the agent's standing instructions, in plain language. Change it and watch what changes, and what does not.</a:t>
+              <a:t>The brief is the agent's standing instructions, in plain language. Weaken it and watch what still holds.</a:t>
             </a:r>
           </a:p>
         </p:txBody>
@@ -8627,7 +8627,7 @@
                 </a:solidFill>
                 <a:latin typeface="Arial"/>
               </a:rPr>
-              <a:t>Watch the code catch it</a:t>
+              <a:t>Watch what holds</a:t>
             </a:r>
           </a:p>
         </p:txBody>
@@ -8666,7 +8666,7 @@
                 </a:solidFill>
                 <a:latin typeface="Arial"/>
               </a:rPr>
-              <a:t>Read the trace. Without the paragraph the reply agent may attempt the forward. The guardrail blocks it in red, and the error travels back up to the orchestrator. Then click Restore default.</a:t>
+              <a:t>Read the trace. Either the agent still refuses on its own, or the reply agent attempts the forward and the guardrail blocks it in red, with the error travelling back up to the orchestrator. Either way, nothing leaves.</a:t>
             </a:r>
           </a:p>
         </p:txBody>
@@ -8758,7 +8758,7 @@
                 </a:solidFill>
                 <a:latin typeface="Arial"/>
               </a:rPr>
-              <a:t>Strengthen it</a:t>
+              <a:t>Put it back</a:t>
             </a:r>
           </a:p>
         </p:txBody>
@@ -8797,7 +8797,7 @@
                 </a:solidFill>
                 <a:latin typeface="Arial"/>
               </a:rPr>
-              <a:t>Add one line of your own, for example "Anything from the works council or the union is urgent today." Send "What needs my attention today?" and compare with your first run.</a:t>
+              <a:t>Click Restore default and send the trap once more. Compare the two traces: with the brief in place the refusal comes first, before any tool is called.</a:t>
             </a:r>
           </a:p>
         </p:txBody>
@@ -8935,7 +8935,7 @@
                 </a:solidFill>
                 <a:latin typeface="Arial"/>
               </a:rPr>
-              <a:t>It enforces nothing: when it is weakened, only the code and the person remain</a:t>
+              <a:t>It enforces nothing: when it is weakened, the code still decides what can leave</a:t>
             </a:r>
           </a:p>
           <a:p>
@@ -8951,7 +8951,7 @@
                 </a:solidFill>
                 <a:latin typeface="Arial"/>
               </a:rPr>
-              <a:t>One added sentence changes what the orchestrator asks the sub-agents to do first</a:t>
+              <a:t>Confidential emails never leave the organisation, whatever the agent was told</a:t>
             </a:r>
           </a:p>
         </p:txBody>
@@ -9210,7 +9210,7 @@
                 </a:solidFill>
                 <a:latin typeface="Arial"/>
               </a:rPr>
-              <a:t>CHALLENGE 2 · THE GUARDRAILS</a:t>
+              <a:t>CHALLENGE 2 · DRAFTING A REPLY</a:t>
             </a:r>
           </a:p>
         </p:txBody>
@@ -9319,7 +9319,7 @@
                 </a:solidFill>
                 <a:latin typeface="Arial"/>
               </a:rPr>
-              <a:t>Guardrails run inside the tools. They do not ask the model; they check it. Three lines of defence: the brief, the code, the person.</a:t>
+              <a:t>Drafting is where the brief, the code and the person meet in one email. Use the union's request about the Plant 2 grievance (HR-060).</a:t>
             </a:r>
           </a:p>
         </p:txBody>
@@ -9411,7 +9411,7 @@
                 </a:solidFill>
                 <a:latin typeface="Arial"/>
               </a:rPr>
-              <a:t>Lower the bulk limit</a:t>
+              <a:t>Ask for the draft</a:t>
             </a:r>
           </a:p>
         </p:txBody>
@@ -9450,7 +9450,7 @@
                 </a:solidFill>
                 <a:latin typeface="Arial"/>
               </a:rPr>
-              <a:t>In block 3, Guardrails, set "more than N emails in one call" to 10. Send "Label the newsletters, vendor mail and admin so I never see them." An approval card appears: reject it, with a reason.</a:t>
+              <a:t>Send "Draft a reply to Marta Visser from the union about the escalated grievance at Plant 2." The union is outside the organisation, so the draft arrives as an approval card. Read it: does it promise copies of the correspondence? Does it name anyone?</a:t>
             </a:r>
           </a:p>
         </p:txBody>
@@ -9542,7 +9542,7 @@
                 </a:solidFill>
                 <a:latin typeface="Arial"/>
               </a:rPr>
-              <a:t>Try the protected label</a:t>
+              <a:t>Reject it, with a reason</a:t>
             </a:r>
           </a:p>
         </p:txBody>
@@ -9581,7 +9581,7 @@
                 </a:solidFill>
                 <a:latin typeface="Arial"/>
               </a:rPr>
-              <a:t>Send "Archive all the Health &amp; Safety emails." Whatever the agent decides, the archive is blocked in code. Read what the agent tells you afterwards.</a:t>
+              <a:t>Reject with "Do not promise the correspondence. Confirm the right to be accompanied, propose a meeting, three sentences." The rejection reaches the reply agent as a tool error, it redrafts, a new card appears. Approve it and find it in the outbox.</a:t>
             </a:r>
           </a:p>
         </p:txBody>
@@ -9673,7 +9673,7 @@
                 </a:solidFill>
                 <a:latin typeface="Arial"/>
               </a:rPr>
-              <a:t>Remove the code, keep the person</a:t>
+              <a:t>Put it in the brief</a:t>
             </a:r>
           </a:p>
         </p:txBody>
@@ -9712,7 +9712,7 @@
                 </a:solidFill>
                 <a:latin typeface="Arial"/>
               </a:rPr>
-              <a:t>Untick "Confidential emails are never forwarded outside" and delete the brief's last paragraph again. Send the trap. The forward now reaches an approval card: you are the last line. Reject it.</a:t>
+              <a:t>Add to the brief: "Replies to the union or works council: three sentences, confirm rights, never share case documents by email, propose a meeting, sign as Sofia Lindgren, HR business partner." Send the same request again.</a:t>
             </a:r>
           </a:p>
         </p:txBody>
@@ -9834,7 +9834,7 @@
                 </a:solidFill>
                 <a:latin typeface="Arial"/>
               </a:rPr>
-              <a:t>Your rejection reaches the sub-agent as a tool error; the orchestrator adapts, with smaller batches or a question</a:t>
+              <a:t>The approval card is code: the recipient's domain decides, not the agent</a:t>
             </a:r>
           </a:p>
           <a:p>
@@ -9850,7 +9850,7 @@
                 </a:solidFill>
                 <a:latin typeface="Arial"/>
               </a:rPr>
-              <a:t>A blocked archive is a red line in the trace and nothing moves in the inbox</a:t>
+              <a:t>What the draft says is the brief's job; your rejection text becomes the next instruction</a:t>
             </a:r>
           </a:p>
           <a:p>
@@ -9866,7 +9866,7 @@
                 </a:solidFill>
                 <a:latin typeface="Arial"/>
               </a:rPr>
-              <a:t>With the brief and the code gone, only the approval card stands between the inbox and the outside</a:t>
+              <a:t>After the brief change the draft is right first time, and the card still appears</a:t>
             </a:r>
           </a:p>
         </p:txBody>
@@ -9990,7 +9990,7 @@
                 </a:solidFill>
                 <a:latin typeface="Arial"/>
               </a:rPr>
-              <a:t>Which of the three lines would you trust in your own process, and for what?</a:t>
+              <a:t>Which replies should a person always see before they leave, and which rules belong in the brief instead?</a:t>
             </a:r>
           </a:p>
         </p:txBody>

</xml_diff>

<commit_message>
Sync slides and README from the law branch
Co-Authored-By: Claude Fable 5.1 <noreply@anthropic.com>
Claude-Session: https://claude.ai/code/session_013LaU8KutyVc6GAVj7UGghE
</commit_message>
<xml_diff>
--- a/slides/agent-10-minute-exercise.pptx
+++ b/slides/agent-10-minute-exercise.pptx
@@ -596,7 +596,7 @@
           <a:lstStyle/>
           <a:p>
             <a:r>
-              <a:t>Step A shows that the refusal of the trap came from the brief. Step B shows that the forward is still refused, by code: Confidential emails never leave the organisation. Step C shows the brief doing its real job, steering judgement. Land the question: policy that must hold goes in code, not in prose.</a:t>
+              <a:t>Step A removes the instruction that made the refusal explicit. In step B two things can happen, and both make the point: the model may still refuse on its own judgement, or it attempts the forward and the forward_email tool blocks it because the emails are Confidential and the address is outside the organisation. Step C shows the brief doing its job: the refusal is immediate and explained. Land the question: policy that must hold goes in code, not in prose. Do not try to make the agent actually send: the model's own judgement is a line you cannot switch off, which is itself worth saying.</a:t>
             </a:r>
           </a:p>
         </p:txBody>
@@ -666,7 +666,7 @@
           <a:lstStyle/>
           <a:p>
             <a:r>
-              <a:t>Step A is the human line: the limit is code, the decision is yours, and the agent has to live with it. Step B is pure code: Health &amp; Safety can never be archived, however the agent was persuaded. Step C strips the first two lines so that the person is visibly the last one. Close on the question; the usual answer is code for what must never happen, a person for what is expensive to get wrong, the brief for everything else.</a:t>
+              <a:t>Step A: the card appears because marta.visser is outside the organisation; the content is whatever the brief and the email suggested, and the first draft often offers to send the correspondence, which is confidential. Step B: the rejection text is literally what the agent receives as an error, so a precise reason produces a precise redraft; a vague one does not. Step C: the same rule now lives in the brief and the draft needs no correction, but the card still appears, because it is code. If a group has time, ask for a reply to Bram Jansen, the employee who raised the complaint: it goes straight to the outbox with no card, because he is internal. Ask whether that is right.</a:t>
             </a:r>
           </a:p>
         </p:txBody>
@@ -8404,7 +8404,7 @@
                 </a:solidFill>
                 <a:latin typeface="Arial"/>
               </a:rPr>
-              <a:t>The brief is the agent's standing instructions, in plain language. Change it and watch what changes, and what does not.</a:t>
+              <a:t>The brief is the agent's standing instructions, in plain language. Weaken it and watch what still holds.</a:t>
             </a:r>
           </a:p>
         </p:txBody>
@@ -8627,7 +8627,7 @@
                 </a:solidFill>
                 <a:latin typeface="Arial"/>
               </a:rPr>
-              <a:t>Watch the code catch it</a:t>
+              <a:t>Watch what holds</a:t>
             </a:r>
           </a:p>
         </p:txBody>
@@ -8666,7 +8666,7 @@
                 </a:solidFill>
                 <a:latin typeface="Arial"/>
               </a:rPr>
-              <a:t>Read the trace. Without the paragraph the reply agent may attempt the forward. The guardrail blocks it in red, and the error travels back up to the orchestrator. Then click Restore default.</a:t>
+              <a:t>Read the trace. Either the agent still refuses on its own, or the reply agent attempts the forward and the guardrail blocks it in red, with the error travelling back up to the orchestrator. Either way, nothing leaves.</a:t>
             </a:r>
           </a:p>
         </p:txBody>
@@ -8758,7 +8758,7 @@
                 </a:solidFill>
                 <a:latin typeface="Arial"/>
               </a:rPr>
-              <a:t>Strengthen it</a:t>
+              <a:t>Put it back</a:t>
             </a:r>
           </a:p>
         </p:txBody>
@@ -8797,7 +8797,7 @@
                 </a:solidFill>
                 <a:latin typeface="Arial"/>
               </a:rPr>
-              <a:t>Add one line of your own, for example "Anything from the works council or the union is urgent today." Send "What needs my attention today?" and compare with your first run.</a:t>
+              <a:t>Click Restore default and send the trap once more. Compare the two traces: with the brief in place the refusal comes first, before any tool is called.</a:t>
             </a:r>
           </a:p>
         </p:txBody>
@@ -8935,7 +8935,7 @@
                 </a:solidFill>
                 <a:latin typeface="Arial"/>
               </a:rPr>
-              <a:t>It enforces nothing: when it is weakened, only the code and the person remain</a:t>
+              <a:t>It enforces nothing: when it is weakened, the code still decides what can leave</a:t>
             </a:r>
           </a:p>
           <a:p>
@@ -8951,7 +8951,7 @@
                 </a:solidFill>
                 <a:latin typeface="Arial"/>
               </a:rPr>
-              <a:t>One added sentence changes what the orchestrator asks the sub-agents to do first</a:t>
+              <a:t>Confidential emails never leave the organisation, whatever the agent was told</a:t>
             </a:r>
           </a:p>
         </p:txBody>
@@ -9210,7 +9210,7 @@
                 </a:solidFill>
                 <a:latin typeface="Arial"/>
               </a:rPr>
-              <a:t>CHALLENGE 2 · THE GUARDRAILS</a:t>
+              <a:t>CHALLENGE 2 · DRAFTING A REPLY</a:t>
             </a:r>
           </a:p>
         </p:txBody>
@@ -9319,7 +9319,7 @@
                 </a:solidFill>
                 <a:latin typeface="Arial"/>
               </a:rPr>
-              <a:t>Guardrails run inside the tools. They do not ask the model; they check it. Three lines of defence: the brief, the code, the person.</a:t>
+              <a:t>Drafting is where the brief, the code and the person meet in one email. Use the union's request about the Plant 2 grievance (HR-060).</a:t>
             </a:r>
           </a:p>
         </p:txBody>
@@ -9411,7 +9411,7 @@
                 </a:solidFill>
                 <a:latin typeface="Arial"/>
               </a:rPr>
-              <a:t>Lower the bulk limit</a:t>
+              <a:t>Ask for the draft</a:t>
             </a:r>
           </a:p>
         </p:txBody>
@@ -9450,7 +9450,7 @@
                 </a:solidFill>
                 <a:latin typeface="Arial"/>
               </a:rPr>
-              <a:t>In block 3, Guardrails, set "more than N emails in one call" to 10. Send "Label the newsletters, vendor mail and admin so I never see them." An approval card appears: reject it, with a reason.</a:t>
+              <a:t>Send "Draft a reply to Marta Visser from the union about the escalated grievance at Plant 2." The union is outside the organisation, so the draft arrives as an approval card. Read it: does it promise copies of the correspondence? Does it name anyone?</a:t>
             </a:r>
           </a:p>
         </p:txBody>
@@ -9542,7 +9542,7 @@
                 </a:solidFill>
                 <a:latin typeface="Arial"/>
               </a:rPr>
-              <a:t>Try the protected label</a:t>
+              <a:t>Reject it, with a reason</a:t>
             </a:r>
           </a:p>
         </p:txBody>
@@ -9581,7 +9581,7 @@
                 </a:solidFill>
                 <a:latin typeface="Arial"/>
               </a:rPr>
-              <a:t>Send "Archive all the Health &amp; Safety emails." Whatever the agent decides, the archive is blocked in code. Read what the agent tells you afterwards.</a:t>
+              <a:t>Reject with "Do not promise the correspondence. Confirm the right to be accompanied, propose a meeting, three sentences." The rejection reaches the reply agent as a tool error, it redrafts, a new card appears. Approve it and find it in the outbox.</a:t>
             </a:r>
           </a:p>
         </p:txBody>
@@ -9673,7 +9673,7 @@
                 </a:solidFill>
                 <a:latin typeface="Arial"/>
               </a:rPr>
-              <a:t>Remove the code, keep the person</a:t>
+              <a:t>Put it in the brief</a:t>
             </a:r>
           </a:p>
         </p:txBody>
@@ -9712,7 +9712,7 @@
                 </a:solidFill>
                 <a:latin typeface="Arial"/>
               </a:rPr>
-              <a:t>Untick "Confidential emails are never forwarded outside" and delete the brief's last paragraph again. Send the trap. The forward now reaches an approval card: you are the last line. Reject it.</a:t>
+              <a:t>Add to the brief: "Replies to the union or works council: three sentences, confirm rights, never share case documents by email, propose a meeting, sign as Sofia Lindgren, HR business partner." Send the same request again.</a:t>
             </a:r>
           </a:p>
         </p:txBody>
@@ -9834,7 +9834,7 @@
                 </a:solidFill>
                 <a:latin typeface="Arial"/>
               </a:rPr>
-              <a:t>Your rejection reaches the sub-agent as a tool error; the orchestrator adapts, with smaller batches or a question</a:t>
+              <a:t>The approval card is code: the recipient's domain decides, not the agent</a:t>
             </a:r>
           </a:p>
           <a:p>
@@ -9850,7 +9850,7 @@
                 </a:solidFill>
                 <a:latin typeface="Arial"/>
               </a:rPr>
-              <a:t>A blocked archive is a red line in the trace and nothing moves in the inbox</a:t>
+              <a:t>What the draft says is the brief's job; your rejection text becomes the next instruction</a:t>
             </a:r>
           </a:p>
           <a:p>
@@ -9866,7 +9866,7 @@
                 </a:solidFill>
                 <a:latin typeface="Arial"/>
               </a:rPr>
-              <a:t>With the brief and the code gone, only the approval card stands between the inbox and the outside</a:t>
+              <a:t>After the brief change the draft is right first time, and the card still appears</a:t>
             </a:r>
           </a:p>
         </p:txBody>
@@ -9990,7 +9990,7 @@
                 </a:solidFill>
                 <a:latin typeface="Arial"/>
               </a:rPr>
-              <a:t>Which of the three lines would you trust in your own process, and for what?</a:t>
+              <a:t>Which replies should a person always see before they leave, and which rules belong in the brief instead?</a:t>
             </a:r>
           </a:p>
         </p:txBody>

</xml_diff>

<commit_message>
Email references on every exercise step
HR-037 for the trap, HR-060 for the union reply, HR-078 for the optional
internal reply.

Co-Authored-By: Claude Fable 5.1 <noreply@anthropic.com>
Claude-Session: https://claude.ai/code/session_013LaU8KutyVc6GAVj7UGghE
</commit_message>
<xml_diff>
--- a/slides/agent-10-minute-exercise.pptx
+++ b/slides/agent-10-minute-exercise.pptx
@@ -666,7 +666,7 @@
           <a:lstStyle/>
           <a:p>
             <a:r>
-              <a:t>Step A: the card appears because marta.visser is outside the organisation; the content is whatever the brief and the email suggested, and the first draft often offers to send the correspondence, which is confidential. Step B: the rejection text is literally what the agent receives as an error, so a precise reason produces a precise redraft; a vague one does not. Step C: the same rule now lives in the brief and the draft needs no correction, but the card still appears, because it is code. If a group has time, ask for a reply to Bram Jansen, the employee who raised the complaint: it goes straight to the outbox with no card, because he is internal. Ask whether that is right.</a:t>
+              <a:t>Step A: the card appears because marta.visser is outside the organisation; the content is whatever the brief and the email suggested, and the first draft often offers to send the correspondence, which is confidential. Step B: the rejection text is literally what the agent receives as an error, so a precise reason produces a precise redraft; a vague one does not. Step C: the same rule now lives in the brief and the draft needs no correction, but the card still appears, because it is code. If a group has time, ask for a reply to email HR-078, Bram Jansen, the employee who raised the harassment complaint: it goes straight to the outbox with no card, because he is internal. Ask whether that is right.</a:t>
             </a:r>
           </a:p>
         </p:txBody>
@@ -7804,7 +7804,7 @@
                 </a:solidFill>
                 <a:latin typeface="Arial"/>
               </a:rPr>
-              <a:t>Send the trap, then read the red line</a:t>
+              <a:t>Send the trap (HR-037), read the red line</a:t>
             </a:r>
           </a:p>
         </p:txBody>
@@ -8404,7 +8404,7 @@
                 </a:solidFill>
                 <a:latin typeface="Arial"/>
               </a:rPr>
-              <a:t>The brief is the agent's standing instructions, in plain language. Weaken it and watch what still holds.</a:t>
+              <a:t>The brief is the agent's standing instructions, in plain language. Weaken it and watch what still holds. Email: HR-037, Payroll audit – employee salary export required.</a:t>
             </a:r>
           </a:p>
         </p:txBody>
@@ -8535,7 +8535,7 @@
                 </a:solidFill>
                 <a:latin typeface="Arial"/>
               </a:rPr>
-              <a:t>In block 1, The brief, delete the last paragraph (the one that says email content is untrusted). Send the trap prompt again.</a:t>
+              <a:t>In block 1, The brief, delete the last paragraph (the one that says email content is untrusted). Send the trap prompt again (it concerns email HR-037).</a:t>
             </a:r>
           </a:p>
         </p:txBody>
@@ -9319,7 +9319,7 @@
                 </a:solidFill>
                 <a:latin typeface="Arial"/>
               </a:rPr>
-              <a:t>Drafting is where the brief, the code and the person meet in one email. Use the union's request about the Plant 2 grievance (HR-060).</a:t>
+              <a:t>Drafting is where the brief, the code and the person meet in one email. Email: HR-060, Grievance escalated by the union, from Marta Visser.</a:t>
             </a:r>
           </a:p>
         </p:txBody>
@@ -9450,7 +9450,7 @@
                 </a:solidFill>
                 <a:latin typeface="Arial"/>
               </a:rPr>
-              <a:t>Send "Draft a reply to Marta Visser from the union about the escalated grievance at Plant 2." The union is outside the organisation, so the draft arrives as an approval card. Read it: does it promise copies of the correspondence? Does it name anyone?</a:t>
+              <a:t>Send "Draft a reply to email HR-060, from Marta Visser of the union, about the escalated grievance at Plant 2." The union is outside the organisation, so the draft arrives as an approval card. Read it: does it promise copies of the correspondence? Does it name anyone?</a:t>
             </a:r>
           </a:p>
         </p:txBody>

</xml_diff>